<commit_message>
Publish approved Al Khor local evidence, improved map, twelve-slide pitch and expanded verification
</commit_message>
<xml_diff>
--- a/docs/UrbanHeat-AlKhor-Pitch.pptx
+++ b/docs/UrbanHeat-AlKhor-Pitch.pptx
@@ -2,24 +2,24 @@
 <file path=ppt/presentation.xml><?xml version="1.0" encoding="utf-8"?>
 <p:presentation xmlns:p="http://schemas.openxmlformats.org/presentationml/2006/main">
   <p:sldMasterIdLst>
-    <p:sldMasterId xmlns:r="http://schemas.openxmlformats.org/officeDocument/2006/relationships" id="2147483648" r:id="Re80ca79e434e4ded"/>
+    <p:sldMasterId xmlns:r="http://schemas.openxmlformats.org/officeDocument/2006/relationships" id="2147483648" r:id="Rc437e29670fc4762"/>
   </p:sldMasterIdLst>
   <p:notesMasterIdLst>
-    <p:notesMasterId xmlns:r="http://schemas.openxmlformats.org/officeDocument/2006/relationships" r:id="Rc583a4e9a70440a7"/>
+    <p:notesMasterId xmlns:r="http://schemas.openxmlformats.org/officeDocument/2006/relationships" r:id="R28d2207b92b74de5"/>
   </p:notesMasterIdLst>
   <p:sldIdLst>
-    <p:sldId xmlns:r="http://schemas.openxmlformats.org/officeDocument/2006/relationships" id="256" r:id="R1f526fcc3cf040cf"/>
-    <p:sldId xmlns:r="http://schemas.openxmlformats.org/officeDocument/2006/relationships" id="257" r:id="R19354e73806c4dac"/>
-    <p:sldId xmlns:r="http://schemas.openxmlformats.org/officeDocument/2006/relationships" id="258" r:id="Rd05897d5d56f4035"/>
-    <p:sldId xmlns:r="http://schemas.openxmlformats.org/officeDocument/2006/relationships" id="259" r:id="R3519f3cdacb246c5"/>
-    <p:sldId xmlns:r="http://schemas.openxmlformats.org/officeDocument/2006/relationships" id="260" r:id="R98657c5e61414512"/>
-    <p:sldId xmlns:r="http://schemas.openxmlformats.org/officeDocument/2006/relationships" id="261" r:id="R0f82b68dea1b4033"/>
-    <p:sldId xmlns:r="http://schemas.openxmlformats.org/officeDocument/2006/relationships" id="262" r:id="R7ad0e5a3ac8543d0"/>
-    <p:sldId xmlns:r="http://schemas.openxmlformats.org/officeDocument/2006/relationships" id="263" r:id="R810dfe4007ef4b32"/>
-    <p:sldId xmlns:r="http://schemas.openxmlformats.org/officeDocument/2006/relationships" id="264" r:id="R87dcd1c41bfa4214"/>
-    <p:sldId xmlns:r="http://schemas.openxmlformats.org/officeDocument/2006/relationships" id="265" r:id="R5149f4673a724f6b"/>
-    <p:sldId xmlns:r="http://schemas.openxmlformats.org/officeDocument/2006/relationships" id="266" r:id="Rd17822387aff468f"/>
-    <p:sldId xmlns:r="http://schemas.openxmlformats.org/officeDocument/2006/relationships" id="267" r:id="R0641597b74464282"/>
+    <p:sldId xmlns:r="http://schemas.openxmlformats.org/officeDocument/2006/relationships" id="256" r:id="Rf4dfa02a48924dcf"/>
+    <p:sldId xmlns:r="http://schemas.openxmlformats.org/officeDocument/2006/relationships" id="257" r:id="R0250ceb3d43b4cc6"/>
+    <p:sldId xmlns:r="http://schemas.openxmlformats.org/officeDocument/2006/relationships" id="258" r:id="Rc4430c007319428f"/>
+    <p:sldId xmlns:r="http://schemas.openxmlformats.org/officeDocument/2006/relationships" id="259" r:id="Rb75867a560004dce"/>
+    <p:sldId xmlns:r="http://schemas.openxmlformats.org/officeDocument/2006/relationships" id="260" r:id="Ra6ab6ed3f820402b"/>
+    <p:sldId xmlns:r="http://schemas.openxmlformats.org/officeDocument/2006/relationships" id="261" r:id="Rccdadf42f21b4c97"/>
+    <p:sldId xmlns:r="http://schemas.openxmlformats.org/officeDocument/2006/relationships" id="262" r:id="R3b750980735b4ee1"/>
+    <p:sldId xmlns:r="http://schemas.openxmlformats.org/officeDocument/2006/relationships" id="263" r:id="R5c132eb2fd26463b"/>
+    <p:sldId xmlns:r="http://schemas.openxmlformats.org/officeDocument/2006/relationships" id="264" r:id="R1e6dfe076abe496f"/>
+    <p:sldId xmlns:r="http://schemas.openxmlformats.org/officeDocument/2006/relationships" id="265" r:id="R7dcee3cb8d6f4bc1"/>
+    <p:sldId xmlns:r="http://schemas.openxmlformats.org/officeDocument/2006/relationships" id="266" r:id="Rb133d68c9d5a4136"/>
+    <p:sldId xmlns:r="http://schemas.openxmlformats.org/officeDocument/2006/relationships" id="267" r:id="R9916258caeda435b"/>
   </p:sldIdLst>
   <p:sldSz cx="12192000" cy="6858000"/>
   <p:notesSz cx="6858000" cy="9144000"/>
@@ -523,7 +523,7 @@
           <a:lstStyle xmlns:a="http://schemas.openxmlformats.org/drawingml/2006/main"/>
           <a:p xmlns:a="http://schemas.openxmlformats.org/drawingml/2006/main">
             <a:r>
-              <a:t>Proposed next-stage activities, not completed work. See README sections 1, 2 and 8. A planner partnership, field validation and suitable imagery are dependencies; no partner agreement or funded incubation is claimed.</a:t>
+              <a:t>Proposed next-stage activities, not completed work. See README sections 1, 2 and 8. A planner partnership, field validation and suitable imagery are dependencies; no partner agreement or funded incubation is claimed. No additional thermal date or historical change measurement was added in this local-review revision.</a:t>
             </a:r>
           </a:p>
         </p:txBody>
@@ -593,7 +593,7 @@
           <a:lstStyle xmlns:a="http://schemas.openxmlformats.org/drawingml/2006/main"/>
           <a:p xmlns:a="http://schemas.openxmlformats.org/drawingml/2006/main">
             <a:r>
-              <a:t>Team responsibilities selected by Nasser on 5 October 2026. Nasser is the registered team leader. Assigned member checks remain pending; this slide does not record completed work. Submission requires final approval and evaluator access remains pending.</a:t>
+              <a:t>Nasser selected responsibilities on 5 October 2026. Abdulrahman supplied the observations in the teammate notes, recorded 6 October 2026. Nasser reports visiting the sites and confirms the described physical situation is the same as in September 2026. Exact visit dates were not supplied; detailed measurements remain pending. Other members retain the assigned responsibilities, without claimed completion. Repository visibility verified public; submission requires final approval.</a:t>
             </a:r>
           </a:p>
         </p:txBody>
@@ -663,7 +663,7 @@
           <a:lstStyle xmlns:a="http://schemas.openxmlformats.org/drawingml/2006/main"/>
           <a:p xmlns:a="http://schemas.openxmlformats.org/drawingml/2006/main">
             <a:r>
-              <a:t>Sources: README sections 3 and 10, DATA-LICENSES.md, scene.json, landsat-scene.json and metadata. These are dataset attributions, not claims of field validation.</a:t>
+              <a:t>Sources: README sections 3 and 10, DATA-LICENSES.md, scene.json, landsat-scene.json and metadata. These are dataset attributions, not claims of field validation. Instructor recommended Copernicus Browser (https://browser.dataspace.copernicus.eu/ ; official documentation checked: https://documentation.dataspace.copernicus.eu/Applications/Browser.html), NASA Earthdata supplied dashboard link (https://earthdata.nasa.gov/dashboard ; exact destination unconfirmed), Bellingcat geolocation toolkit (https://bellingcat.gitbook.io/toolkit/categories/geolocation ; checked). NASA Worldview was an additional suggestion, not the instructor exact link. No data provenance was changed to these portals. Full supplied instructor links and verification status are in docs/Discovery-Resources.md. Earth Search remains optical download provenance and Planetary Computer thermal provenance. WorldCover DOI and OSM licence above are retained. Street View reference is linked, capture March 2023; no Google imagery redistributed.</a:t>
             </a:r>
           </a:p>
         </p:txBody>
@@ -803,7 +803,7 @@
           <a:lstStyle xmlns:a="http://schemas.openxmlformats.org/drawingml/2006/main"/>
           <a:p xmlns:a="http://schemas.openxmlformats.org/drawingml/2006/main">
             <a:r>
-              <a:t>Source: README sections 1, 2 and 8. The use case is proposed, not validated with users.</a:t>
+              <a:t>Source: docs/Local-Review.md, results/local-greenery-audit.json and unchanged planning-cells.csv. Local observer: Abdulrahman Almohannadi; reports recorded 6 October 2026, observation date unspecified. Street View link supplied by Nasser: https://maps.app.goo.gl/gPEzxW3NFqErPWNP8 . Panorama McFzT23rIzQ4UJTSgSHFCQ, capture March 2023. Camera 25.7175476, 51.5145504 is inside V04-23, about 84 m from its centre, not a surveyed sign coordinate. It provides historical context, historical imagery, supplemented by Nasser's firsthand report. Some tree shadow is visible; shade varies. Nasser reports visiting the sites and confirms the described physical situation is the same as in September 2026; exact visit dates were not supplied. No passenger counts, cooling benefits or design recommendations are established. Street View imagery is linked, not redistributed. Google guidance: https://about.google/brand-resource-center/products-and-services/geo-guidelines/ .</a:t>
             </a:r>
           </a:p>
         </p:txBody>
@@ -943,7 +943,7 @@
           <a:lstStyle xmlns:a="http://schemas.openxmlformats.org/drawingml/2006/main"/>
           <a:p xmlns:a="http://schemas.openxmlformats.org/drawingml/2006/main">
             <a:r>
-              <a:t>Editable workflow diagram. Methods are detailed in README section 4. Inputs are 35 hashed files; matching support is required for the two accepted thermal dates. Ranking is an investigation heuristic.</a:t>
+              <a:t>Editable workflow diagram. Methods are detailed in README section 4. Inputs are 35 hashed files; matching support is required for the two accepted thermal dates. Ranking is an investigation heuristic. Local review is a separate evidence stage. It does not alter the satellite ranking or create a human-use score.</a:t>
             </a:r>
           </a:p>
         </p:txBody>
@@ -1013,7 +1013,7 @@
           <a:lstStyle xmlns:a="http://schemas.openxmlformats.org/drawingml/2006/main"/>
           <a:p xmlns:a="http://schemas.openxmlformats.org/drawingml/2006/main">
             <a:r>
-              <a:t>Source: results/planning-map.png, results/planning-summary.json and aoi.geojson. WGS84 window 51.445-51.555 E, 25.635-25.730 N. Includes city, northern edge, Al Bayt Stadium and surrounding context. It is not an official administrative boundary. All source-image labels must remain visible.</a:t>
+              <a:t>Source: results/local-review-map.png, packaged Sentinel-2 RGB 30 September 2026, app/local-review.json, aoi.geojson and unchanged planning-cells.geojson. Labels identify the full 300 m polygons. Teal dashed line is the analyst-defined study boundary. Local location names and uses are from Abdulrahman; Nasser confirms site visits and unchanged physical conditions relative to September 2026; exact visit dates unspecified, detailed assessment pending. V04-23 and V04-24 are adjacent; a nearby farmers market has not been assigned to a cell. Street View marker is the historical camera, not an exact stop point. Contains modified Copernicus Sentinel data (2026).</a:t>
             </a:r>
           </a:p>
         </p:txBody>
@@ -1083,7 +1083,7 @@
           <a:lstStyle xmlns:a="http://schemas.openxmlformats.org/drawingml/2006/main"/>
           <a:p xmlns:a="http://schemas.openxmlformats.org/drawingml/2006/main">
             <a:r>
-              <a:t>Source: results/multidate-temperature.png and coastal-multidate-summary.json. The two accepted dates share screened support. Footprint is observed sample area, not total built-up city area. Surface temperature is not air temperature or heat-health risk.</a:t>
+              <a:t>Source: results/multidate-temperature.png and coastal-multidate-summary.json. The two accepted dates share screened support. Footprint is observed sample area, not total built-up city area. Surface temperature is not air temperature or heat-health risk. Updated display uses the two unchanged common-temp rasters with a common 30–60 °C scale. The rejected 6 September date is explained in text instead of an empty map; its exclusion record is preserved.</a:t>
             </a:r>
           </a:p>
         </p:txBody>
@@ -1153,7 +1153,7 @@
           <a:lstStyle xmlns:a="http://schemas.openxmlformats.org/drawingml/2006/main"/>
           <a:p xmlns:a="http://schemas.openxmlformats.org/drawingml/2006/main">
             <a:r>
-              <a:t>Source: results/planning-summary.json, planning-sensitivity.csv and README section 8. Green-pixel share is thresholded NDVI, not subpixel vegetation fraction. Building coverage is contributed and incomplete. Candidate retained sample footprint totals 31.8195 km².</a:t>
+              <a:t>Source: results/planning-summary.json, planning-sensitivity.csv and README section 8. Green-pixel share is thresholded NDVI, not subpixel vegetation fraction. Building coverage is contributed and incomplete. Candidate retained sample footprint totals 31.8195 km². Local observations: docs/Local-Review.md; Nasser confirms site visits; detailed assessment pending. V04-23 maxima are 0.26262 and 0.24985; matched-support shares at diagnostic threshold 0.20 are 2.7222% and 0.3889%. Nasser confirms roadside trees and unchanged physical conditions relative to September 2026 from site visits; exact visit dates were not supplied. This does not validate the optical threshold or vegetation health. Scenario ranks remain unchanged; no unique certified intervention site. The fixed score weights remain 50% heat, 30% inverse green, 20% mapped buildings.</a:t>
             </a:r>
           </a:p>
         </p:txBody>
@@ -1223,7 +1223,7 @@
           <a:lstStyle xmlns:a="http://schemas.openxmlformats.org/drawingml/2006/main"/>
           <a:p xmlns:a="http://schemas.openxmlformats.org/drawingml/2006/main">
             <a:r>
-              <a:t>Source: README sections 6 and 8, reference-samples.csv, notebook-verification.json when available. 20/30 coastal references agree with the spectral/QA screen. All 30 OSM water-polygon references disagree, with some contributed polygons spanning dry land. These positive-only agreement tests do not establish overall accuracy. Reproducibility does not establish scientific accuracy. Normal-kernel verification: https://github.com/NasserAlhuri/spaceHacathon/actions/runs/37269889977. Source commit 9781b95a46d86eb858ae9714ee53198ad22cfb6c. The executed notebook was retrieved from artifact 11328001190. All seven regenerated CSV tables match the supplied baseline byte for byte.</a:t>
+              <a:t>Source: README sections 6 and 8, reference-samples.csv, notebook-verification.json when available. 20/30 coastal references agree with the spectral/QA screen. All 30 OSM water-polygon references disagree, with some contributed polygons spanning dry land. These positive-only agreement tests do not establish overall accuracy. Reproducibility does not establish scientific accuracy. Normal-kernel verification: https://github.com/NasserAlhuri/spaceHacathon/actions/runs/37269889977. Source commit 9781b95a46d86eb858ae9714ee53198ad22cfb6c. The executed notebook was retrieved from artifact 11328001190. All seven regenerated CSV tables match the supplied baseline byte for byte. These are rule-agreement checks on contributed positive reference points, not overall accuracy. The separate local pixel audit reproduces the baseline V04-23 result; it is not independent thermal or vegetation calibration.</a:t>
             </a:r>
           </a:p>
         </p:txBody>
@@ -1342,6 +1342,7 @@
                 <a:spcPts val="0"/>
               </a:spcAft>
               <a:buNone/>
+              <a:defRPr/>
             </a:lvl1pPr>
             <a:lvl2pPr marL="0" indent="0">
               <a:lnSpc>
@@ -1354,6 +1355,7 @@
                 <a:spcPts val="0"/>
               </a:spcAft>
               <a:buNone/>
+              <a:defRPr/>
             </a:lvl2pPr>
             <a:lvl3pPr marL="0" indent="0">
               <a:lnSpc>
@@ -1366,6 +1368,7 @@
                 <a:spcPts val="0"/>
               </a:spcAft>
               <a:buNone/>
+              <a:defRPr/>
             </a:lvl3pPr>
             <a:lvl4pPr marL="0" indent="0">
               <a:lnSpc>
@@ -1378,6 +1381,7 @@
                 <a:spcPts val="0"/>
               </a:spcAft>
               <a:buNone/>
+              <a:defRPr/>
             </a:lvl4pPr>
             <a:lvl5pPr marL="0" indent="0">
               <a:lnSpc>
@@ -1390,6 +1394,7 @@
                 <a:spcPts val="0"/>
               </a:spcAft>
               <a:buNone/>
+              <a:defRPr/>
             </a:lvl5pPr>
             <a:lvl6pPr marL="0" indent="0">
               <a:lnSpc>
@@ -1402,6 +1407,7 @@
                 <a:spcPts val="0"/>
               </a:spcAft>
               <a:buNone/>
+              <a:defRPr/>
             </a:lvl6pPr>
             <a:lvl7pPr marL="0" indent="0">
               <a:lnSpc>
@@ -1414,6 +1420,7 @@
                 <a:spcPts val="0"/>
               </a:spcAft>
               <a:buNone/>
+              <a:defRPr/>
             </a:lvl7pPr>
             <a:lvl8pPr marL="0" indent="0">
               <a:lnSpc>
@@ -1426,6 +1433,7 @@
                 <a:spcPts val="0"/>
               </a:spcAft>
               <a:buNone/>
+              <a:defRPr/>
             </a:lvl8pPr>
             <a:lvl9pPr marL="0" indent="0">
               <a:lnSpc>
@@ -1438,6 +1446,7 @@
                 <a:spcPts val="0"/>
               </a:spcAft>
               <a:buNone/>
+              <a:defRPr/>
             </a:lvl9pPr>
           </a:lstStyle>
           <a:p xmlns:a="http://schemas.openxmlformats.org/drawingml/2006/main"/>
@@ -1489,6 +1498,7 @@
                 <a:spcPts val="0"/>
               </a:spcAft>
               <a:buNone/>
+              <a:defRPr/>
             </a:lvl1pPr>
             <a:lvl2pPr marL="0" indent="0">
               <a:lnSpc>
@@ -1501,6 +1511,7 @@
                 <a:spcPts val="0"/>
               </a:spcAft>
               <a:buNone/>
+              <a:defRPr/>
             </a:lvl2pPr>
             <a:lvl3pPr marL="0" indent="0">
               <a:lnSpc>
@@ -1513,6 +1524,7 @@
                 <a:spcPts val="0"/>
               </a:spcAft>
               <a:buNone/>
+              <a:defRPr/>
             </a:lvl3pPr>
             <a:lvl4pPr marL="0" indent="0">
               <a:lnSpc>
@@ -1525,6 +1537,7 @@
                 <a:spcPts val="0"/>
               </a:spcAft>
               <a:buNone/>
+              <a:defRPr/>
             </a:lvl4pPr>
             <a:lvl5pPr marL="0" indent="0">
               <a:lnSpc>
@@ -1537,6 +1550,7 @@
                 <a:spcPts val="0"/>
               </a:spcAft>
               <a:buNone/>
+              <a:defRPr/>
             </a:lvl5pPr>
             <a:lvl6pPr marL="0" indent="0">
               <a:lnSpc>
@@ -1549,6 +1563,7 @@
                 <a:spcPts val="0"/>
               </a:spcAft>
               <a:buNone/>
+              <a:defRPr/>
             </a:lvl6pPr>
             <a:lvl7pPr marL="0" indent="0">
               <a:lnSpc>
@@ -1561,6 +1576,7 @@
                 <a:spcPts val="0"/>
               </a:spcAft>
               <a:buNone/>
+              <a:defRPr/>
             </a:lvl7pPr>
             <a:lvl8pPr marL="0" indent="0">
               <a:lnSpc>
@@ -1573,6 +1589,7 @@
                 <a:spcPts val="0"/>
               </a:spcAft>
               <a:buNone/>
+              <a:defRPr/>
             </a:lvl8pPr>
             <a:lvl9pPr marL="0" indent="0">
               <a:lnSpc>
@@ -1585,6 +1602,7 @@
                 <a:spcPts val="0"/>
               </a:spcAft>
               <a:buNone/>
+              <a:defRPr/>
             </a:lvl9pPr>
           </a:lstStyle>
           <a:p xmlns:a="http://schemas.openxmlformats.org/drawingml/2006/main"/>
@@ -1684,6 +1702,7 @@
                 <a:spcPts val="0"/>
               </a:spcAft>
               <a:buNone/>
+              <a:defRPr/>
             </a:lvl1pPr>
             <a:lvl2pPr marL="0" indent="0">
               <a:lnSpc>
@@ -1696,6 +1715,7 @@
                 <a:spcPts val="0"/>
               </a:spcAft>
               <a:buNone/>
+              <a:defRPr/>
             </a:lvl2pPr>
             <a:lvl3pPr marL="0" indent="0">
               <a:lnSpc>
@@ -1708,6 +1728,7 @@
                 <a:spcPts val="0"/>
               </a:spcAft>
               <a:buNone/>
+              <a:defRPr/>
             </a:lvl3pPr>
             <a:lvl4pPr marL="0" indent="0">
               <a:lnSpc>
@@ -1720,6 +1741,7 @@
                 <a:spcPts val="0"/>
               </a:spcAft>
               <a:buNone/>
+              <a:defRPr/>
             </a:lvl4pPr>
             <a:lvl5pPr marL="0" indent="0">
               <a:lnSpc>
@@ -1732,6 +1754,7 @@
                 <a:spcPts val="0"/>
               </a:spcAft>
               <a:buNone/>
+              <a:defRPr/>
             </a:lvl5pPr>
             <a:lvl6pPr marL="0" indent="0">
               <a:lnSpc>
@@ -1744,6 +1767,7 @@
                 <a:spcPts val="0"/>
               </a:spcAft>
               <a:buNone/>
+              <a:defRPr/>
             </a:lvl6pPr>
             <a:lvl7pPr marL="0" indent="0">
               <a:lnSpc>
@@ -1756,6 +1780,7 @@
                 <a:spcPts val="0"/>
               </a:spcAft>
               <a:buNone/>
+              <a:defRPr/>
             </a:lvl7pPr>
             <a:lvl8pPr marL="0" indent="0">
               <a:lnSpc>
@@ -1768,6 +1793,7 @@
                 <a:spcPts val="0"/>
               </a:spcAft>
               <a:buNone/>
+              <a:defRPr/>
             </a:lvl8pPr>
             <a:lvl9pPr marL="0" indent="0">
               <a:lnSpc>
@@ -1780,6 +1806,7 @@
                 <a:spcPts val="0"/>
               </a:spcAft>
               <a:buNone/>
+              <a:defRPr/>
             </a:lvl9pPr>
           </a:lstStyle>
           <a:p xmlns:a="http://schemas.openxmlformats.org/drawingml/2006/main"/>
@@ -1879,6 +1906,7 @@
                 <a:spcPts val="0"/>
               </a:spcAft>
               <a:buNone/>
+              <a:defRPr/>
             </a:lvl1pPr>
             <a:lvl2pPr marL="0" indent="0">
               <a:lnSpc>
@@ -1891,6 +1919,7 @@
                 <a:spcPts val="0"/>
               </a:spcAft>
               <a:buNone/>
+              <a:defRPr/>
             </a:lvl2pPr>
             <a:lvl3pPr marL="0" indent="0">
               <a:lnSpc>
@@ -1903,6 +1932,7 @@
                 <a:spcPts val="0"/>
               </a:spcAft>
               <a:buNone/>
+              <a:defRPr/>
             </a:lvl3pPr>
             <a:lvl4pPr marL="0" indent="0">
               <a:lnSpc>
@@ -1915,6 +1945,7 @@
                 <a:spcPts val="0"/>
               </a:spcAft>
               <a:buNone/>
+              <a:defRPr/>
             </a:lvl4pPr>
             <a:lvl5pPr marL="0" indent="0">
               <a:lnSpc>
@@ -1927,6 +1958,7 @@
                 <a:spcPts val="0"/>
               </a:spcAft>
               <a:buNone/>
+              <a:defRPr/>
             </a:lvl5pPr>
             <a:lvl6pPr marL="0" indent="0">
               <a:lnSpc>
@@ -1939,6 +1971,7 @@
                 <a:spcPts val="0"/>
               </a:spcAft>
               <a:buNone/>
+              <a:defRPr/>
             </a:lvl6pPr>
             <a:lvl7pPr marL="0" indent="0">
               <a:lnSpc>
@@ -1951,6 +1984,7 @@
                 <a:spcPts val="0"/>
               </a:spcAft>
               <a:buNone/>
+              <a:defRPr/>
             </a:lvl7pPr>
             <a:lvl8pPr marL="0" indent="0">
               <a:lnSpc>
@@ -1963,6 +1997,7 @@
                 <a:spcPts val="0"/>
               </a:spcAft>
               <a:buNone/>
+              <a:defRPr/>
             </a:lvl8pPr>
             <a:lvl9pPr marL="0" indent="0">
               <a:lnSpc>
@@ -1975,6 +2010,7 @@
                 <a:spcPts val="0"/>
               </a:spcAft>
               <a:buNone/>
+              <a:defRPr/>
             </a:lvl9pPr>
           </a:lstStyle>
           <a:p xmlns:a="http://schemas.openxmlformats.org/drawingml/2006/main"/>
@@ -2026,6 +2062,7 @@
                 <a:spcPts val="1200"/>
               </a:spcAft>
               <a:buChar char="•"/>
+              <a:defRPr/>
             </a:lvl1pPr>
             <a:lvl2pPr marL="533400" indent="-228600">
               <a:lnSpc>
@@ -2038,6 +2075,7 @@
                 <a:spcPts val="1200"/>
               </a:spcAft>
               <a:buChar char="•"/>
+              <a:defRPr/>
             </a:lvl2pPr>
             <a:lvl3pPr marL="838200" indent="-228600">
               <a:lnSpc>
@@ -2050,6 +2088,7 @@
                 <a:spcPts val="1200"/>
               </a:spcAft>
               <a:buChar char="•"/>
+              <a:defRPr/>
             </a:lvl3pPr>
             <a:lvl4pPr marL="1143000" indent="-228600">
               <a:lnSpc>
@@ -2062,6 +2101,7 @@
                 <a:spcPts val="1200"/>
               </a:spcAft>
               <a:buChar char="•"/>
+              <a:defRPr/>
             </a:lvl4pPr>
             <a:lvl5pPr marL="1447800" indent="-228600">
               <a:lnSpc>
@@ -2074,6 +2114,7 @@
                 <a:spcPts val="1200"/>
               </a:spcAft>
               <a:buChar char="•"/>
+              <a:defRPr/>
             </a:lvl5pPr>
             <a:lvl6pPr marL="1752600" indent="-228600">
               <a:lnSpc>
@@ -2086,6 +2127,7 @@
                 <a:spcPts val="1200"/>
               </a:spcAft>
               <a:buChar char="•"/>
+              <a:defRPr/>
             </a:lvl6pPr>
             <a:lvl7pPr marL="2057400" indent="-228600">
               <a:lnSpc>
@@ -2098,6 +2140,7 @@
                 <a:spcPts val="1200"/>
               </a:spcAft>
               <a:buChar char="•"/>
+              <a:defRPr/>
             </a:lvl7pPr>
             <a:lvl8pPr marL="2362200" indent="-228600">
               <a:lnSpc>
@@ -2110,6 +2153,7 @@
                 <a:spcPts val="1200"/>
               </a:spcAft>
               <a:buChar char="•"/>
+              <a:defRPr/>
             </a:lvl8pPr>
             <a:lvl9pPr marL="2667000" indent="-228600">
               <a:lnSpc>
@@ -2122,6 +2166,7 @@
                 <a:spcPts val="1200"/>
               </a:spcAft>
               <a:buChar char="•"/>
+              <a:defRPr/>
             </a:lvl9pPr>
           </a:lstStyle>
           <a:p xmlns:a="http://schemas.openxmlformats.org/drawingml/2006/main"/>
@@ -2221,6 +2266,7 @@
                 <a:spcPts val="0"/>
               </a:spcAft>
               <a:buNone/>
+              <a:defRPr/>
             </a:lvl1pPr>
             <a:lvl2pPr marL="0" indent="0">
               <a:lnSpc>
@@ -2233,6 +2279,7 @@
                 <a:spcPts val="0"/>
               </a:spcAft>
               <a:buNone/>
+              <a:defRPr/>
             </a:lvl2pPr>
             <a:lvl3pPr marL="0" indent="0">
               <a:lnSpc>
@@ -2245,6 +2292,7 @@
                 <a:spcPts val="0"/>
               </a:spcAft>
               <a:buNone/>
+              <a:defRPr/>
             </a:lvl3pPr>
             <a:lvl4pPr marL="0" indent="0">
               <a:lnSpc>
@@ -2257,6 +2305,7 @@
                 <a:spcPts val="0"/>
               </a:spcAft>
               <a:buNone/>
+              <a:defRPr/>
             </a:lvl4pPr>
             <a:lvl5pPr marL="0" indent="0">
               <a:lnSpc>
@@ -2269,6 +2318,7 @@
                 <a:spcPts val="0"/>
               </a:spcAft>
               <a:buNone/>
+              <a:defRPr/>
             </a:lvl5pPr>
             <a:lvl6pPr marL="0" indent="0">
               <a:lnSpc>
@@ -2281,6 +2331,7 @@
                 <a:spcPts val="0"/>
               </a:spcAft>
               <a:buNone/>
+              <a:defRPr/>
             </a:lvl6pPr>
             <a:lvl7pPr marL="0" indent="0">
               <a:lnSpc>
@@ -2293,6 +2344,7 @@
                 <a:spcPts val="0"/>
               </a:spcAft>
               <a:buNone/>
+              <a:defRPr/>
             </a:lvl7pPr>
             <a:lvl8pPr marL="0" indent="0">
               <a:lnSpc>
@@ -2305,6 +2357,7 @@
                 <a:spcPts val="0"/>
               </a:spcAft>
               <a:buNone/>
+              <a:defRPr/>
             </a:lvl8pPr>
             <a:lvl9pPr marL="0" indent="0">
               <a:lnSpc>
@@ -2317,6 +2370,7 @@
                 <a:spcPts val="0"/>
               </a:spcAft>
               <a:buNone/>
+              <a:defRPr/>
             </a:lvl9pPr>
           </a:lstStyle>
           <a:p xmlns:a="http://schemas.openxmlformats.org/drawingml/2006/main"/>
@@ -2368,6 +2422,7 @@
                 <a:spcPts val="1200"/>
               </a:spcAft>
               <a:buChar char="•"/>
+              <a:defRPr/>
             </a:lvl1pPr>
             <a:lvl2pPr marL="533400" indent="-228600">
               <a:lnSpc>
@@ -2380,6 +2435,7 @@
                 <a:spcPts val="1200"/>
               </a:spcAft>
               <a:buChar char="•"/>
+              <a:defRPr/>
             </a:lvl2pPr>
             <a:lvl3pPr marL="838200" indent="-228600">
               <a:lnSpc>
@@ -2392,6 +2448,7 @@
                 <a:spcPts val="1200"/>
               </a:spcAft>
               <a:buChar char="•"/>
+              <a:defRPr/>
             </a:lvl3pPr>
             <a:lvl4pPr marL="1143000" indent="-228600">
               <a:lnSpc>
@@ -2404,6 +2461,7 @@
                 <a:spcPts val="1200"/>
               </a:spcAft>
               <a:buChar char="•"/>
+              <a:defRPr/>
             </a:lvl4pPr>
             <a:lvl5pPr marL="1447800" indent="-228600">
               <a:lnSpc>
@@ -2416,6 +2474,7 @@
                 <a:spcPts val="1200"/>
               </a:spcAft>
               <a:buChar char="•"/>
+              <a:defRPr/>
             </a:lvl5pPr>
             <a:lvl6pPr marL="1752600" indent="-228600">
               <a:lnSpc>
@@ -2428,6 +2487,7 @@
                 <a:spcPts val="1200"/>
               </a:spcAft>
               <a:buChar char="•"/>
+              <a:defRPr/>
             </a:lvl6pPr>
             <a:lvl7pPr marL="2057400" indent="-228600">
               <a:lnSpc>
@@ -2440,6 +2500,7 @@
                 <a:spcPts val="1200"/>
               </a:spcAft>
               <a:buChar char="•"/>
+              <a:defRPr/>
             </a:lvl7pPr>
             <a:lvl8pPr marL="2362200" indent="-228600">
               <a:lnSpc>
@@ -2452,6 +2513,7 @@
                 <a:spcPts val="1200"/>
               </a:spcAft>
               <a:buChar char="•"/>
+              <a:defRPr/>
             </a:lvl8pPr>
             <a:lvl9pPr marL="2667000" indent="-228600">
               <a:lnSpc>
@@ -2464,6 +2526,7 @@
                 <a:spcPts val="1200"/>
               </a:spcAft>
               <a:buChar char="•"/>
+              <a:defRPr/>
             </a:lvl9pPr>
           </a:lstStyle>
           <a:p xmlns:a="http://schemas.openxmlformats.org/drawingml/2006/main"/>
@@ -2515,6 +2578,7 @@
                 <a:spcPts val="1200"/>
               </a:spcAft>
               <a:buChar char="•"/>
+              <a:defRPr/>
             </a:lvl1pPr>
             <a:lvl2pPr marL="533400" indent="-228600">
               <a:lnSpc>
@@ -2527,6 +2591,7 @@
                 <a:spcPts val="1200"/>
               </a:spcAft>
               <a:buChar char="•"/>
+              <a:defRPr/>
             </a:lvl2pPr>
             <a:lvl3pPr marL="838200" indent="-228600">
               <a:lnSpc>
@@ -2539,6 +2604,7 @@
                 <a:spcPts val="1200"/>
               </a:spcAft>
               <a:buChar char="•"/>
+              <a:defRPr/>
             </a:lvl3pPr>
             <a:lvl4pPr marL="1143000" indent="-228600">
               <a:lnSpc>
@@ -2551,6 +2617,7 @@
                 <a:spcPts val="1200"/>
               </a:spcAft>
               <a:buChar char="•"/>
+              <a:defRPr/>
             </a:lvl4pPr>
             <a:lvl5pPr marL="1447800" indent="-228600">
               <a:lnSpc>
@@ -2563,6 +2630,7 @@
                 <a:spcPts val="1200"/>
               </a:spcAft>
               <a:buChar char="•"/>
+              <a:defRPr/>
             </a:lvl5pPr>
             <a:lvl6pPr marL="1752600" indent="-228600">
               <a:lnSpc>
@@ -2575,6 +2643,7 @@
                 <a:spcPts val="1200"/>
               </a:spcAft>
               <a:buChar char="•"/>
+              <a:defRPr/>
             </a:lvl6pPr>
             <a:lvl7pPr marL="2057400" indent="-228600">
               <a:lnSpc>
@@ -2587,6 +2656,7 @@
                 <a:spcPts val="1200"/>
               </a:spcAft>
               <a:buChar char="•"/>
+              <a:defRPr/>
             </a:lvl7pPr>
             <a:lvl8pPr marL="2362200" indent="-228600">
               <a:lnSpc>
@@ -2599,6 +2669,7 @@
                 <a:spcPts val="1200"/>
               </a:spcAft>
               <a:buChar char="•"/>
+              <a:defRPr/>
             </a:lvl8pPr>
             <a:lvl9pPr marL="2667000" indent="-228600">
               <a:lnSpc>
@@ -2611,6 +2682,7 @@
                 <a:spcPts val="1200"/>
               </a:spcAft>
               <a:buChar char="•"/>
+              <a:defRPr/>
             </a:lvl9pPr>
           </a:lstStyle>
           <a:p xmlns:a="http://schemas.openxmlformats.org/drawingml/2006/main"/>
@@ -2710,6 +2782,7 @@
                 <a:spcPts val="0"/>
               </a:spcAft>
               <a:buNone/>
+              <a:defRPr/>
             </a:lvl1pPr>
             <a:lvl2pPr marL="0" indent="0">
               <a:lnSpc>
@@ -2722,6 +2795,7 @@
                 <a:spcPts val="0"/>
               </a:spcAft>
               <a:buNone/>
+              <a:defRPr/>
             </a:lvl2pPr>
             <a:lvl3pPr marL="0" indent="0">
               <a:lnSpc>
@@ -2734,6 +2808,7 @@
                 <a:spcPts val="0"/>
               </a:spcAft>
               <a:buNone/>
+              <a:defRPr/>
             </a:lvl3pPr>
             <a:lvl4pPr marL="0" indent="0">
               <a:lnSpc>
@@ -2746,6 +2821,7 @@
                 <a:spcPts val="0"/>
               </a:spcAft>
               <a:buNone/>
+              <a:defRPr/>
             </a:lvl4pPr>
             <a:lvl5pPr marL="0" indent="0">
               <a:lnSpc>
@@ -2758,6 +2834,7 @@
                 <a:spcPts val="0"/>
               </a:spcAft>
               <a:buNone/>
+              <a:defRPr/>
             </a:lvl5pPr>
             <a:lvl6pPr marL="0" indent="0">
               <a:lnSpc>
@@ -2770,6 +2847,7 @@
                 <a:spcPts val="0"/>
               </a:spcAft>
               <a:buNone/>
+              <a:defRPr/>
             </a:lvl6pPr>
             <a:lvl7pPr marL="0" indent="0">
               <a:lnSpc>
@@ -2782,6 +2860,7 @@
                 <a:spcPts val="0"/>
               </a:spcAft>
               <a:buNone/>
+              <a:defRPr/>
             </a:lvl7pPr>
             <a:lvl8pPr marL="0" indent="0">
               <a:lnSpc>
@@ -2794,6 +2873,7 @@
                 <a:spcPts val="0"/>
               </a:spcAft>
               <a:buNone/>
+              <a:defRPr/>
             </a:lvl8pPr>
             <a:lvl9pPr marL="0" indent="0">
               <a:lnSpc>
@@ -2806,6 +2886,7 @@
                 <a:spcPts val="0"/>
               </a:spcAft>
               <a:buNone/>
+              <a:defRPr/>
             </a:lvl9pPr>
           </a:lstStyle>
           <a:p xmlns:a="http://schemas.openxmlformats.org/drawingml/2006/main"/>
@@ -2857,6 +2938,7 @@
                 <a:spcPts val="1200"/>
               </a:spcAft>
               <a:buChar char="•"/>
+              <a:defRPr/>
             </a:lvl1pPr>
             <a:lvl2pPr marL="533400" indent="-228600">
               <a:lnSpc>
@@ -2869,6 +2951,7 @@
                 <a:spcPts val="1200"/>
               </a:spcAft>
               <a:buChar char="•"/>
+              <a:defRPr/>
             </a:lvl2pPr>
             <a:lvl3pPr marL="838200" indent="-228600">
               <a:lnSpc>
@@ -2881,6 +2964,7 @@
                 <a:spcPts val="1200"/>
               </a:spcAft>
               <a:buChar char="•"/>
+              <a:defRPr/>
             </a:lvl3pPr>
             <a:lvl4pPr marL="1143000" indent="-228600">
               <a:lnSpc>
@@ -2893,6 +2977,7 @@
                 <a:spcPts val="1200"/>
               </a:spcAft>
               <a:buChar char="•"/>
+              <a:defRPr/>
             </a:lvl4pPr>
             <a:lvl5pPr marL="1447800" indent="-228600">
               <a:lnSpc>
@@ -2905,6 +2990,7 @@
                 <a:spcPts val="1200"/>
               </a:spcAft>
               <a:buChar char="•"/>
+              <a:defRPr/>
             </a:lvl5pPr>
             <a:lvl6pPr marL="1752600" indent="-228600">
               <a:lnSpc>
@@ -2917,6 +3003,7 @@
                 <a:spcPts val="1200"/>
               </a:spcAft>
               <a:buChar char="•"/>
+              <a:defRPr/>
             </a:lvl6pPr>
             <a:lvl7pPr marL="2057400" indent="-228600">
               <a:lnSpc>
@@ -2929,6 +3016,7 @@
                 <a:spcPts val="1200"/>
               </a:spcAft>
               <a:buChar char="•"/>
+              <a:defRPr/>
             </a:lvl7pPr>
             <a:lvl8pPr marL="2362200" indent="-228600">
               <a:lnSpc>
@@ -2941,6 +3029,7 @@
                 <a:spcPts val="1200"/>
               </a:spcAft>
               <a:buChar char="•"/>
+              <a:defRPr/>
             </a:lvl8pPr>
             <a:lvl9pPr marL="2667000" indent="-228600">
               <a:lnSpc>
@@ -2953,6 +3042,7 @@
                 <a:spcPts val="1200"/>
               </a:spcAft>
               <a:buChar char="•"/>
+              <a:defRPr/>
             </a:lvl9pPr>
           </a:lstStyle>
           <a:p xmlns:a="http://schemas.openxmlformats.org/drawingml/2006/main"/>
@@ -3001,12 +3091,12 @@
   </p:cSld>
   <p:clrMap bg1="lt1" tx1="dk1" bg2="lt2" tx2="dk2" accent1="accent1" accent2="accent2" accent3="accent3" accent4="accent4" accent5="accent5" accent6="accent6" hlink="hlink" folHlink="folHlink"/>
   <p:sldLayoutIdLst>
-    <p:sldLayoutId xmlns:r="http://schemas.openxmlformats.org/officeDocument/2006/relationships" id="2147483649" r:id="R6fa0ba1da8e74b4f"/>
-    <p:sldLayoutId xmlns:r="http://schemas.openxmlformats.org/officeDocument/2006/relationships" id="2147483650" r:id="R290a17db494c42c4"/>
-    <p:sldLayoutId xmlns:r="http://schemas.openxmlformats.org/officeDocument/2006/relationships" id="2147483651" r:id="Re1671ec289cf4bbc"/>
-    <p:sldLayoutId xmlns:r="http://schemas.openxmlformats.org/officeDocument/2006/relationships" id="2147483652" r:id="Ree9590e89ea84bea"/>
-    <p:sldLayoutId xmlns:r="http://schemas.openxmlformats.org/officeDocument/2006/relationships" id="2147483653" r:id="R05cf4cc4e4404ac3"/>
-    <p:sldLayoutId xmlns:r="http://schemas.openxmlformats.org/officeDocument/2006/relationships" id="2147483654" r:id="R2f0d121ca90b423e"/>
+    <p:sldLayoutId xmlns:r="http://schemas.openxmlformats.org/officeDocument/2006/relationships" id="2147483649" r:id="R04a2e35cbca445b6"/>
+    <p:sldLayoutId xmlns:r="http://schemas.openxmlformats.org/officeDocument/2006/relationships" id="2147483650" r:id="Ra5cbe0d6cd41483f"/>
+    <p:sldLayoutId xmlns:r="http://schemas.openxmlformats.org/officeDocument/2006/relationships" id="2147483651" r:id="R4babc2ac96dd42ea"/>
+    <p:sldLayoutId xmlns:r="http://schemas.openxmlformats.org/officeDocument/2006/relationships" id="2147483652" r:id="Rab3c85198230416a"/>
+    <p:sldLayoutId xmlns:r="http://schemas.openxmlformats.org/officeDocument/2006/relationships" id="2147483653" r:id="Rab95646195c74f4a"/>
+    <p:sldLayoutId xmlns:r="http://schemas.openxmlformats.org/officeDocument/2006/relationships" id="2147483654" r:id="R1efd1f59c2ea4a76"/>
   </p:sldLayoutIdLst>
   <p:txStyles>
     <p:titleStyle>
@@ -3586,6 +3676,7 @@
           <a:lstStyle xmlns:a="http://schemas.openxmlformats.org/drawingml/2006/main"/>
           <a:p xmlns:a="http://schemas.openxmlformats.org/drawingml/2006/main">
             <a:pPr>
+              <a:buNone/>
               <a:defRPr sz="5400" b="1">
                 <a:solidFill>
                   <a:srgbClr val="163D46"/>
@@ -3643,6 +3734,7 @@
           <a:lstStyle xmlns:a="http://schemas.openxmlformats.org/drawingml/2006/main"/>
           <a:p xmlns:a="http://schemas.openxmlformats.org/drawingml/2006/main">
             <a:pPr>
+              <a:buNone/>
               <a:defRPr sz="3000" b="0">
                 <a:solidFill>
                   <a:srgbClr val="213846"/>
@@ -3700,6 +3792,7 @@
           <a:lstStyle xmlns:a="http://schemas.openxmlformats.org/drawingml/2006/main"/>
           <a:p xmlns:a="http://schemas.openxmlformats.org/drawingml/2006/main">
             <a:pPr>
+              <a:buNone/>
               <a:defRPr sz="2250" b="0">
                 <a:solidFill>
                   <a:srgbClr val="213846"/>
@@ -3757,6 +3850,7 @@
           <a:lstStyle xmlns:a="http://schemas.openxmlformats.org/drawingml/2006/main"/>
           <a:p xmlns:a="http://schemas.openxmlformats.org/drawingml/2006/main">
             <a:pPr>
+              <a:buNone/>
               <a:defRPr sz="2250" b="0">
                 <a:solidFill>
                   <a:srgbClr val="213846"/>
@@ -3775,7 +3869,7 @@
                 <a:ea typeface="Bitstream Charter"/>
                 <a:cs typeface="Bitstream Charter"/>
               </a:rPr>
-              <a:t>Satellite indicators for urban-planning site visits</a:t>
+              <a:t>Satellite and local evidence for heat-protection site assessments</a:t>
             </a:r>
           </a:p>
         </p:txBody>
@@ -3814,6 +3908,7 @@
           <a:lstStyle xmlns:a="http://schemas.openxmlformats.org/drawingml/2006/main"/>
           <a:p xmlns:a="http://schemas.openxmlformats.org/drawingml/2006/main">
             <a:pPr>
+              <a:buNone/>
               <a:defRPr sz="2250" b="0">
                 <a:solidFill>
                   <a:srgbClr val="213846"/>
@@ -3871,6 +3966,7 @@
           <a:lstStyle xmlns:a="http://schemas.openxmlformats.org/drawingml/2006/main"/>
           <a:p xmlns:a="http://schemas.openxmlformats.org/drawingml/2006/main">
             <a:pPr>
+              <a:buNone/>
               <a:defRPr sz="2250" b="0">
                 <a:solidFill>
                   <a:srgbClr val="213846"/>
@@ -3957,6 +4053,7 @@
           <a:lstStyle xmlns:a="http://schemas.openxmlformats.org/drawingml/2006/main"/>
           <a:p xmlns:a="http://schemas.openxmlformats.org/drawingml/2006/main">
             <a:pPr>
+              <a:buNone/>
               <a:defRPr sz="3300" b="1">
                 <a:solidFill>
                   <a:srgbClr val="163D46"/>
@@ -4014,6 +4111,7 @@
           <a:lstStyle xmlns:a="http://schemas.openxmlformats.org/drawingml/2006/main"/>
           <a:p xmlns:a="http://schemas.openxmlformats.org/drawingml/2006/main">
             <a:pPr>
+              <a:buNone/>
               <a:defRPr sz="2400" b="0">
                 <a:solidFill>
                   <a:srgbClr val="213846"/>
@@ -4032,7 +4130,7 @@
                 <a:ea typeface="Bitstream Charter"/>
                 <a:cs typeface="Bitstream Charter"/>
               </a:rPr>
-              <a:t>Proposed benefit: help planners inspect the evidence behind a shortlist before arranging field visits. No time saving or cooling benefit has been measured.</a:t>
+              <a:t>Completed: reproducible satellite screening, sensitivity checks and local-review examples for site assessment.</a:t>
             </a:r>
           </a:p>
         </p:txBody>
@@ -4071,6 +4169,7 @@
           <a:lstStyle xmlns:a="http://schemas.openxmlformats.org/drawingml/2006/main"/>
           <a:p xmlns:a="http://schemas.openxmlformats.org/drawingml/2006/main">
             <a:pPr>
+              <a:buNone/>
               <a:defRPr sz="2400" b="0">
                 <a:solidFill>
                   <a:srgbClr val="213846"/>
@@ -4089,7 +4188,7 @@
                 <a:ea typeface="Bitstream Charter"/>
                 <a:cs typeface="Bitstream Charter"/>
               </a:rPr>
-              <a:t>Next pilot: confirm boundaries and reference labels, visit candidate sites and collect planner feedback.</a:t>
+              <a:t>Next: detailed shade, use and access checks plus planner feedback; evaluate inspection decisions.</a:t>
             </a:r>
           </a:p>
         </p:txBody>
@@ -4128,6 +4227,7 @@
           <a:lstStyle xmlns:a="http://schemas.openxmlformats.org/drawingml/2006/main"/>
           <a:p xmlns:a="http://schemas.openxmlformats.org/drawingml/2006/main">
             <a:pPr>
+              <a:buNone/>
               <a:defRPr sz="2400" b="0">
                 <a:solidFill>
                   <a:srgbClr val="213846"/>
@@ -4146,7 +4246,7 @@
                 <a:ea typeface="Bitstream Charter"/>
                 <a:cs typeface="Bitstream Charter"/>
               </a:rPr>
-              <a:t>Incubation: assess suitable VHR data, implement and validate segmentation, then test shade and paving indicators.</a:t>
+              <a:t>Future: comparable imagery across years, suitable VHR segmentation and verified shade, paving and human-use data.</a:t>
             </a:r>
           </a:p>
         </p:txBody>
@@ -4185,6 +4285,7 @@
           <a:lstStyle xmlns:a="http://schemas.openxmlformats.org/drawingml/2006/main"/>
           <a:p xmlns:a="http://schemas.openxmlformats.org/drawingml/2006/main">
             <a:pPr>
+              <a:buNone/>
               <a:defRPr sz="1725" b="0">
                 <a:solidFill>
                   <a:srgbClr val="526569"/>
@@ -4271,6 +4372,7 @@
           <a:lstStyle xmlns:a="http://schemas.openxmlformats.org/drawingml/2006/main"/>
           <a:p xmlns:a="http://schemas.openxmlformats.org/drawingml/2006/main">
             <a:pPr>
+              <a:buNone/>
               <a:defRPr sz="3300" b="1">
                 <a:solidFill>
                   <a:srgbClr val="163D46"/>
@@ -4328,6 +4430,7 @@
           <a:lstStyle xmlns:a="http://schemas.openxmlformats.org/drawingml/2006/main"/>
           <a:p xmlns:a="http://schemas.openxmlformats.org/drawingml/2006/main">
             <a:pPr>
+              <a:buNone/>
               <a:defRPr sz="2250" b="0">
                 <a:solidFill>
                   <a:srgbClr val="213846"/>
@@ -4346,7 +4449,7 @@
                 <a:ea typeface="Bitstream Charter"/>
                 <a:cs typeface="Bitstream Charter"/>
               </a:rPr>
-              <a:t>Nasser Alhuri: team coordination and submission.</a:t>
+              <a:t>Nasser Alhuri: team coordination, site-visit confirmation and submission.</a:t>
             </a:r>
           </a:p>
         </p:txBody>
@@ -4385,6 +4488,7 @@
           <a:lstStyle xmlns:a="http://schemas.openxmlformats.org/drawingml/2006/main"/>
           <a:p xmlns:a="http://schemas.openxmlformats.org/drawingml/2006/main">
             <a:pPr>
+              <a:buNone/>
               <a:defRPr sz="2250" b="0">
                 <a:solidFill>
                   <a:srgbClr val="213846"/>
@@ -4403,7 +4507,7 @@
                 <a:ea typeface="Bitstream Charter"/>
                 <a:cs typeface="Bitstream Charter"/>
               </a:rPr>
-              <a:t>Abdulrahman Almohannadi: check Al Khor locations against local knowledge.</a:t>
+              <a:t>Abdulrahman Almohannadi: supplied local observations for three cells.</a:t>
             </a:r>
           </a:p>
         </p:txBody>
@@ -4442,6 +4546,7 @@
           <a:lstStyle xmlns:a="http://schemas.openxmlformats.org/drawingml/2006/main"/>
           <a:p xmlns:a="http://schemas.openxmlformats.org/drawingml/2006/main">
             <a:pPr>
+              <a:buNone/>
               <a:defRPr sz="2250" b="0">
                 <a:solidFill>
                   <a:srgbClr val="213846"/>
@@ -4499,6 +4604,7 @@
           <a:lstStyle xmlns:a="http://schemas.openxmlformats.org/drawingml/2006/main"/>
           <a:p xmlns:a="http://schemas.openxmlformats.org/drawingml/2006/main">
             <a:pPr>
+              <a:buNone/>
               <a:defRPr sz="2250" b="0">
                 <a:solidFill>
                   <a:srgbClr val="213846"/>
@@ -4556,6 +4662,7 @@
           <a:lstStyle xmlns:a="http://schemas.openxmlformats.org/drawingml/2006/main"/>
           <a:p xmlns:a="http://schemas.openxmlformats.org/drawingml/2006/main">
             <a:pPr>
+              <a:buNone/>
               <a:defRPr sz="2250" b="0">
                 <a:solidFill>
                   <a:srgbClr val="213846"/>
@@ -4613,6 +4720,7 @@
           <a:lstStyle xmlns:a="http://schemas.openxmlformats.org/drawingml/2006/main"/>
           <a:p xmlns:a="http://schemas.openxmlformats.org/drawingml/2006/main">
             <a:pPr>
+              <a:buNone/>
               <a:defRPr sz="1725" b="0">
                 <a:solidFill>
                   <a:srgbClr val="526569"/>
@@ -4631,7 +4739,7 @@
                 <a:ea typeface="Bitstream Charter"/>
                 <a:cs typeface="Bitstream Charter"/>
               </a:rPr>
-              <a:t>Members will complete their assigned checks before submission.</a:t>
+              <a:t>Nasser confirms site visits; detailed assessment and other assigned reviews remain pending.</a:t>
             </a:r>
           </a:p>
         </p:txBody>
@@ -4699,6 +4807,7 @@
           <a:lstStyle xmlns:a="http://schemas.openxmlformats.org/drawingml/2006/main"/>
           <a:p xmlns:a="http://schemas.openxmlformats.org/drawingml/2006/main">
             <a:pPr>
+              <a:buNone/>
               <a:defRPr sz="3300" b="1">
                 <a:solidFill>
                   <a:srgbClr val="163D46"/>
@@ -4756,6 +4865,7 @@
           <a:lstStyle xmlns:a="http://schemas.openxmlformats.org/drawingml/2006/main"/>
           <a:p xmlns:a="http://schemas.openxmlformats.org/drawingml/2006/main">
             <a:pPr>
+              <a:buNone/>
               <a:defRPr sz="2400" b="0">
                 <a:solidFill>
                   <a:srgbClr val="213846"/>
@@ -4774,7 +4884,7 @@
                 <a:ea typeface="Bitstream Charter"/>
                 <a:cs typeface="Bitstream Charter"/>
               </a:rPr>
-              <a:t>Contains modified Copernicus Sentinel data (2026). Optical source: Element 84 Earth Search.</a:t>
+              <a:t>Actual data: Copernicus Sentinel via Earth Search; Landsat via Planetary Computer (USGS); WorldCover 2021; OSM.</a:t>
             </a:r>
           </a:p>
         </p:txBody>
@@ -4813,6 +4923,7 @@
           <a:lstStyle xmlns:a="http://schemas.openxmlformats.org/drawingml/2006/main"/>
           <a:p xmlns:a="http://schemas.openxmlformats.org/drawingml/2006/main">
             <a:pPr>
+              <a:buNone/>
               <a:defRPr sz="2400" b="0">
                 <a:solidFill>
                   <a:srgbClr val="213846"/>
@@ -4831,7 +4942,7 @@
                 <a:ea typeface="Bitstream Charter"/>
                 <a:cs typeface="Bitstream Charter"/>
               </a:rPr>
-              <a:t>Landsat imagery courtesy of USGS. Collection 2 Level-2 surface temperature, doi:10.5066/P9OGBGM6.</a:t>
+              <a:t>Credits: modified Copernicus Sentinel data (2026); Landsat courtesy USGS; WorldCover CC BY 4.0; OSM ODbL.</a:t>
             </a:r>
           </a:p>
         </p:txBody>
@@ -4870,6 +4981,7 @@
           <a:lstStyle xmlns:a="http://schemas.openxmlformats.org/drawingml/2006/main"/>
           <a:p xmlns:a="http://schemas.openxmlformats.org/drawingml/2006/main">
             <a:pPr>
+              <a:buNone/>
               <a:defRPr sz="2400" b="0">
                 <a:solidFill>
                   <a:srgbClr val="213846"/>
@@ -4888,7 +5000,7 @@
                 <a:ea typeface="Bitstream Charter"/>
                 <a:cs typeface="Bitstream Charter"/>
               </a:rPr>
-              <a:t>ESA WorldCover 2021 v200, Zanaga et al. (2022). CC BY 4.0, doi:10.5281/zenodo.7254220.</a:t>
+              <a:t>Discovery and verification resources: Copernicus Browser, NASA Earthdata and Bellingcat toolkit. These are not new analysis sources.</a:t>
             </a:r>
           </a:p>
         </p:txBody>
@@ -4927,6 +5039,7 @@
           <a:lstStyle xmlns:a="http://schemas.openxmlformats.org/drawingml/2006/main"/>
           <a:p xmlns:a="http://schemas.openxmlformats.org/drawingml/2006/main">
             <a:pPr>
+              <a:buNone/>
               <a:defRPr sz="2400" b="0">
                 <a:solidFill>
                   <a:srgbClr val="213846"/>
@@ -4945,7 +5058,7 @@
                 <a:ea typeface="Bitstream Charter"/>
                 <a:cs typeface="Bitstream Charter"/>
               </a:rPr>
-              <a:t>© OpenStreetMap contributors. Building/reference geometry: ODbL 1.0. openstreetmap.org/copyright</a:t>
+              <a:t/>
             </a:r>
           </a:p>
         </p:txBody>
@@ -4984,6 +5097,7 @@
           <a:lstStyle xmlns:a="http://schemas.openxmlformats.org/drawingml/2006/main"/>
           <a:p xmlns:a="http://schemas.openxmlformats.org/drawingml/2006/main">
             <a:pPr>
+              <a:buNone/>
               <a:defRPr sz="1725" b="0">
                 <a:solidFill>
                   <a:srgbClr val="526569"/>
@@ -5002,7 +5116,7 @@
                 <a:ea typeface="Bitstream Charter"/>
                 <a:cs typeface="Bitstream Charter"/>
               </a:rPr>
-              <a:t>Full scene IDs, exact provenance, processing rules and limitations accompany the package. Original code: MIT.</a:t>
+              <a:t>Exact scene provenance and full licences accompany the package. Original code: MIT.</a:t>
             </a:r>
           </a:p>
         </p:txBody>
@@ -5070,6 +5184,7 @@
           <a:lstStyle xmlns:a="http://schemas.openxmlformats.org/drawingml/2006/main"/>
           <a:p xmlns:a="http://schemas.openxmlformats.org/drawingml/2006/main">
             <a:pPr>
+              <a:buNone/>
               <a:defRPr sz="3300" b="1">
                 <a:solidFill>
                   <a:srgbClr val="163D46"/>
@@ -5127,6 +5242,7 @@
           <a:lstStyle xmlns:a="http://schemas.openxmlformats.org/drawingml/2006/main"/>
           <a:p xmlns:a="http://schemas.openxmlformats.org/drawingml/2006/main">
             <a:pPr>
+              <a:buNone/>
               <a:defRPr sz="2400" b="0">
                 <a:solidFill>
                   <a:srgbClr val="213846"/>
@@ -5145,7 +5261,7 @@
                 <a:ea typeface="Bitstream Charter"/>
                 <a:cs typeface="Bitstream Charter"/>
               </a:rPr>
-              <a:t>Surface heating and limited greenery can help identify places that warrant a closer look.</a:t>
+              <a:t>Find hot cells, then check who uses them and when.</a:t>
             </a:r>
           </a:p>
         </p:txBody>
@@ -5184,6 +5300,7 @@
           <a:lstStyle xmlns:a="http://schemas.openxmlformats.org/drawingml/2006/main"/>
           <a:p xmlns:a="http://schemas.openxmlformats.org/drawingml/2006/main">
             <a:pPr>
+              <a:buNone/>
               <a:defRPr sz="2400" b="0">
                 <a:solidFill>
                   <a:srgbClr val="213846"/>
@@ -5202,7 +5319,7 @@
                 <a:ea typeface="Bitstream Charter"/>
                 <a:cs typeface="Bitstream Charter"/>
               </a:rPr>
-              <a:t>Municipal planners need traceable evidence to organise field investigation before proposing interventions.</a:t>
+              <a:t>Satellite screening helps organise visits; local review adds context about shade, access and planned use.</a:t>
             </a:r>
           </a:p>
         </p:txBody>
@@ -5241,6 +5358,7 @@
           <a:lstStyle xmlns:a="http://schemas.openxmlformats.org/drawingml/2006/main"/>
           <a:p xmlns:a="http://schemas.openxmlformats.org/drawingml/2006/main">
             <a:pPr>
+              <a:buNone/>
               <a:defRPr sz="2400" b="0">
                 <a:solidFill>
                   <a:srgbClr val="213846"/>
@@ -5259,7 +5377,7 @@
                 <a:ea typeface="Bitstream Charter"/>
                 <a:cs typeface="Bitstream Charter"/>
               </a:rPr>
-              <a:t>Pedestrians and outdoor users are the intended beneficiaries. Their exposure and needs have not been measured.</a:t>
+              <a:t>Human exposure has not been measured. Trees, shelters and safer routes are options to assess.</a:t>
             </a:r>
           </a:p>
         </p:txBody>
@@ -5298,6 +5416,7 @@
           <a:lstStyle xmlns:a="http://schemas.openxmlformats.org/drawingml/2006/main"/>
           <a:p xmlns:a="http://schemas.openxmlformats.org/drawingml/2006/main">
             <a:pPr>
+              <a:buNone/>
               <a:defRPr sz="1725" b="0">
                 <a:solidFill>
                   <a:srgbClr val="526569"/>
@@ -5384,6 +5503,7 @@
           <a:lstStyle xmlns:a="http://schemas.openxmlformats.org/drawingml/2006/main"/>
           <a:p xmlns:a="http://schemas.openxmlformats.org/drawingml/2006/main">
             <a:pPr>
+              <a:buNone/>
               <a:defRPr sz="3300" b="1">
                 <a:solidFill>
                   <a:srgbClr val="163D46"/>
@@ -5402,7 +5522,7 @@
                 <a:ea typeface="Bitstream Charter"/>
                 <a:cs typeface="Bitstream Charter"/>
               </a:rPr>
-              <a:t>Planning use case</a:t>
+              <a:t>Bus-stop site assessment: V04-23</a:t>
             </a:r>
           </a:p>
         </p:txBody>
@@ -5441,6 +5561,7 @@
           <a:lstStyle xmlns:a="http://schemas.openxmlformats.org/drawingml/2006/main"/>
           <a:p xmlns:a="http://schemas.openxmlformats.org/drawingml/2006/main">
             <a:pPr>
+              <a:buNone/>
               <a:defRPr sz="2400" b="0">
                 <a:solidFill>
                   <a:srgbClr val="213846"/>
@@ -5459,7 +5580,7 @@
                 <a:ea typeface="Bitstream Charter"/>
                 <a:cs typeface="Bitstream Charter"/>
               </a:rPr>
-              <a:t>A planner needs a shortlist of places to inspect for shade or planting.</a:t>
+              <a:t>Satellite: 50.4 °C mean of two cell medians; 0% detected green pixels at the current threshold.</a:t>
             </a:r>
           </a:p>
         </p:txBody>
@@ -5498,6 +5619,7 @@
           <a:lstStyle xmlns:a="http://schemas.openxmlformats.org/drawingml/2006/main"/>
           <a:p xmlns:a="http://schemas.openxmlformats.org/drawingml/2006/main">
             <a:pPr>
+              <a:buNone/>
               <a:defRPr sz="2400" b="0">
                 <a:solidFill>
                   <a:srgbClr val="213846"/>
@@ -5516,7 +5638,7 @@
                 <a:ea typeface="Bitstream Charter"/>
                 <a:cs typeface="Bitstream Charter"/>
               </a:rPr>
-              <a:t>The map shows observed surface temperature, green signal and mapped buildings for each cell.</a:t>
+              <a:t>Local evidence: roadside trees, no shelter and limited walking access; Nasser confirms site visits.</a:t>
             </a:r>
           </a:p>
         </p:txBody>
@@ -5555,6 +5677,7 @@
           <a:lstStyle xmlns:a="http://schemas.openxmlformats.org/drawingml/2006/main"/>
           <a:p xmlns:a="http://schemas.openxmlformats.org/drawingml/2006/main">
             <a:pPr>
+              <a:buNone/>
               <a:defRPr sz="2400" b="0">
                 <a:solidFill>
                   <a:srgbClr val="213846"/>
@@ -5573,7 +5696,7 @@
                 <a:ea typeface="Bitstream Charter"/>
                 <a:cs typeface="Bitstream Charter"/>
               </a:rPr>
-              <a:t>A site visit must establish pedestrian activity, existing shade, ownership and feasibility.</a:t>
+              <a:t>Next check: waiting-time shade, passenger use, route safety, ownership and feasibility.</a:t>
             </a:r>
           </a:p>
         </p:txBody>
@@ -5612,6 +5735,7 @@
           <a:lstStyle xmlns:a="http://schemas.openxmlformats.org/drawingml/2006/main"/>
           <a:p xmlns:a="http://schemas.openxmlformats.org/drawingml/2006/main">
             <a:pPr>
+              <a:buNone/>
               <a:defRPr sz="1725" b="0">
                 <a:solidFill>
                   <a:srgbClr val="526569"/>
@@ -5630,7 +5754,7 @@
                 <a:ea typeface="Bitstream Charter"/>
                 <a:cs typeface="Bitstream Charter"/>
               </a:rPr>
-              <a:t>No user interview, measured time saving or cooling benefit is claimed.</a:t>
+              <a:t>300 m values are not stop measurements. Nasser confirms unchanged physical conditions; visit dates unspecified.</a:t>
             </a:r>
           </a:p>
         </p:txBody>
@@ -5698,6 +5822,7 @@
           <a:lstStyle xmlns:a="http://schemas.openxmlformats.org/drawingml/2006/main"/>
           <a:p xmlns:a="http://schemas.openxmlformats.org/drawingml/2006/main">
             <a:pPr>
+              <a:buNone/>
               <a:defRPr sz="3300" b="1">
                 <a:solidFill>
                   <a:srgbClr val="163D46"/>
@@ -5755,6 +5880,7 @@
           <a:lstStyle xmlns:a="http://schemas.openxmlformats.org/drawingml/2006/main"/>
           <a:p xmlns:a="http://schemas.openxmlformats.org/drawingml/2006/main">
             <a:pPr>
+              <a:buNone/>
               <a:defRPr sz="2250" b="0">
                 <a:solidFill>
                   <a:srgbClr val="213846"/>
@@ -5812,6 +5938,7 @@
           <a:lstStyle xmlns:a="http://schemas.openxmlformats.org/drawingml/2006/main"/>
           <a:p xmlns:a="http://schemas.openxmlformats.org/drawingml/2006/main">
             <a:pPr>
+              <a:buNone/>
               <a:defRPr sz="2250" b="0">
                 <a:solidFill>
                   <a:srgbClr val="213846"/>
@@ -5869,6 +5996,7 @@
           <a:lstStyle xmlns:a="http://schemas.openxmlformats.org/drawingml/2006/main"/>
           <a:p xmlns:a="http://schemas.openxmlformats.org/drawingml/2006/main">
             <a:pPr>
+              <a:buNone/>
               <a:defRPr sz="2250" b="0">
                 <a:solidFill>
                   <a:srgbClr val="213846"/>
@@ -5926,6 +6054,7 @@
           <a:lstStyle xmlns:a="http://schemas.openxmlformats.org/drawingml/2006/main"/>
           <a:p xmlns:a="http://schemas.openxmlformats.org/drawingml/2006/main">
             <a:pPr>
+              <a:buNone/>
               <a:defRPr sz="2250" b="0">
                 <a:solidFill>
                   <a:srgbClr val="213846"/>
@@ -5983,6 +6112,7 @@
           <a:lstStyle xmlns:a="http://schemas.openxmlformats.org/drawingml/2006/main"/>
           <a:p xmlns:a="http://schemas.openxmlformats.org/drawingml/2006/main">
             <a:pPr>
+              <a:buNone/>
               <a:defRPr sz="1725" b="0">
                 <a:solidFill>
                   <a:srgbClr val="526569"/>
@@ -6037,7 +6167,7 @@
       </p:grpSpPr>
       <p:cxnSp>
         <p:nvCxnSpPr>
-          <p:cNvPr id="17" name=""/>
+          <p:cNvPr id="26" name=""/>
           <p:cNvCxnSpPr>
             <a:stCxn xmlns:a="http://schemas.openxmlformats.org/drawingml/2006/main" id="8" idx="1"/>
             <a:endCxn xmlns:a="http://schemas.openxmlformats.org/drawingml/2006/main" id="10" idx="3"/>
@@ -6062,7 +6192,7 @@
       </p:cxnSp>
       <p:cxnSp>
         <p:nvCxnSpPr>
-          <p:cNvPr id="18" name=""/>
+          <p:cNvPr id="27" name=""/>
           <p:cNvCxnSpPr>
             <a:stCxn xmlns:a="http://schemas.openxmlformats.org/drawingml/2006/main" id="6" idx="2"/>
             <a:endCxn xmlns:a="http://schemas.openxmlformats.org/drawingml/2006/main" id="8" idx="0"/>
@@ -6087,7 +6217,7 @@
       </p:cxnSp>
       <p:cxnSp>
         <p:nvCxnSpPr>
-          <p:cNvPr id="19" name=""/>
+          <p:cNvPr id="28" name=""/>
           <p:cNvCxnSpPr>
             <a:stCxn xmlns:a="http://schemas.openxmlformats.org/drawingml/2006/main" id="4" idx="3"/>
             <a:endCxn xmlns:a="http://schemas.openxmlformats.org/drawingml/2006/main" id="6" idx="1"/>
@@ -6112,7 +6242,7 @@
       </p:cxnSp>
       <p:cxnSp>
         <p:nvCxnSpPr>
-          <p:cNvPr id="20" name=""/>
+          <p:cNvPr id="29" name=""/>
           <p:cNvCxnSpPr>
             <a:stCxn xmlns:a="http://schemas.openxmlformats.org/drawingml/2006/main" id="2" idx="3"/>
             <a:endCxn xmlns:a="http://schemas.openxmlformats.org/drawingml/2006/main" id="4" idx="1"/>
@@ -6169,6 +6299,7 @@
           <a:lstStyle xmlns:a="http://schemas.openxmlformats.org/drawingml/2006/main"/>
           <a:p xmlns:a="http://schemas.openxmlformats.org/drawingml/2006/main">
             <a:pPr>
+              <a:buNone/>
               <a:defRPr sz="3300" b="1">
                 <a:solidFill>
                   <a:srgbClr val="163D46"/>
@@ -6258,6 +6389,7 @@
           <a:lstStyle xmlns:a="http://schemas.openxmlformats.org/drawingml/2006/main"/>
           <a:p xmlns:a="http://schemas.openxmlformats.org/drawingml/2006/main">
             <a:pPr>
+              <a:buNone/>
               <a:defRPr sz="2175" b="0">
                 <a:solidFill>
                   <a:srgbClr val="163D46"/>
@@ -6281,6 +6413,7 @@
           </a:p>
           <a:p xmlns:a="http://schemas.openxmlformats.org/drawingml/2006/main">
             <a:pPr>
+              <a:buNone/>
               <a:defRPr sz="2175" b="0">
                 <a:solidFill>
                   <a:srgbClr val="163D46"/>
@@ -6304,6 +6437,7 @@
           </a:p>
           <a:p xmlns:a="http://schemas.openxmlformats.org/drawingml/2006/main">
             <a:pPr>
+              <a:buNone/>
               <a:defRPr sz="2175" b="0">
                 <a:solidFill>
                   <a:srgbClr val="163D46"/>
@@ -6393,6 +6527,7 @@
           <a:lstStyle xmlns:a="http://schemas.openxmlformats.org/drawingml/2006/main"/>
           <a:p xmlns:a="http://schemas.openxmlformats.org/drawingml/2006/main">
             <a:pPr>
+              <a:buNone/>
               <a:defRPr sz="2175" b="0">
                 <a:solidFill>
                   <a:srgbClr val="163D46"/>
@@ -6416,6 +6551,7 @@
           </a:p>
           <a:p xmlns:a="http://schemas.openxmlformats.org/drawingml/2006/main">
             <a:pPr>
+              <a:buNone/>
               <a:defRPr sz="2175" b="0">
                 <a:solidFill>
                   <a:srgbClr val="163D46"/>
@@ -6439,6 +6575,7 @@
           </a:p>
           <a:p xmlns:a="http://schemas.openxmlformats.org/drawingml/2006/main">
             <a:pPr>
+              <a:buNone/>
               <a:defRPr sz="2175" b="0">
                 <a:solidFill>
                   <a:srgbClr val="163D46"/>
@@ -6528,6 +6665,7 @@
           <a:lstStyle xmlns:a="http://schemas.openxmlformats.org/drawingml/2006/main"/>
           <a:p xmlns:a="http://schemas.openxmlformats.org/drawingml/2006/main">
             <a:pPr>
+              <a:buNone/>
               <a:defRPr sz="2175" b="0">
                 <a:solidFill>
                   <a:srgbClr val="163D46"/>
@@ -6551,6 +6689,7 @@
           </a:p>
           <a:p xmlns:a="http://schemas.openxmlformats.org/drawingml/2006/main">
             <a:pPr>
+              <a:buNone/>
               <a:defRPr sz="2175" b="0">
                 <a:solidFill>
                   <a:srgbClr val="163D46"/>
@@ -6574,6 +6713,7 @@
           </a:p>
           <a:p xmlns:a="http://schemas.openxmlformats.org/drawingml/2006/main">
             <a:pPr>
+              <a:buNone/>
               <a:defRPr sz="2175" b="0">
                 <a:solidFill>
                   <a:srgbClr val="163D46"/>
@@ -6663,6 +6803,7 @@
           <a:lstStyle xmlns:a="http://schemas.openxmlformats.org/drawingml/2006/main"/>
           <a:p xmlns:a="http://schemas.openxmlformats.org/drawingml/2006/main">
             <a:pPr>
+              <a:buNone/>
               <a:defRPr sz="2175" b="0">
                 <a:solidFill>
                   <a:srgbClr val="163D46"/>
@@ -6686,6 +6827,7 @@
           </a:p>
           <a:p xmlns:a="http://schemas.openxmlformats.org/drawingml/2006/main">
             <a:pPr>
+              <a:buNone/>
               <a:defRPr sz="2175" b="0">
                 <a:solidFill>
                   <a:srgbClr val="163D46"/>
@@ -6709,6 +6851,7 @@
           </a:p>
           <a:p xmlns:a="http://schemas.openxmlformats.org/drawingml/2006/main">
             <a:pPr>
+              <a:buNone/>
               <a:defRPr sz="2175" b="0">
                 <a:solidFill>
                   <a:srgbClr val="163D46"/>
@@ -6798,6 +6941,7 @@
           <a:lstStyle xmlns:a="http://schemas.openxmlformats.org/drawingml/2006/main"/>
           <a:p xmlns:a="http://schemas.openxmlformats.org/drawingml/2006/main">
             <a:pPr>
+              <a:buNone/>
               <a:defRPr sz="2175" b="1">
                 <a:solidFill>
                   <a:srgbClr val="163D46"/>
@@ -6816,11 +6960,12 @@
                 <a:ea typeface="Bitstream Charter"/>
                 <a:cs typeface="Bitstream Charter"/>
               </a:rPr>
-              <a:t>Portable map</a:t>
+              <a:t>Local review + map</a:t>
             </a:r>
           </a:p>
           <a:p xmlns:a="http://schemas.openxmlformats.org/drawingml/2006/main">
             <a:pPr>
+              <a:buNone/>
               <a:defRPr sz="2175" b="1">
                 <a:solidFill>
                   <a:srgbClr val="163D46"/>
@@ -6839,11 +6984,12 @@
                 <a:ea typeface="Bitstream Charter"/>
                 <a:cs typeface="Bitstream Charter"/>
               </a:rPr>
-              <a:t>Inspect indicators</a:t>
+              <a:t>Use and shade</a:t>
             </a:r>
           </a:p>
           <a:p xmlns:a="http://schemas.openxmlformats.org/drawingml/2006/main">
             <a:pPr>
+              <a:buNone/>
               <a:defRPr sz="2175" b="1">
                 <a:solidFill>
                   <a:srgbClr val="163D46"/>
@@ -6862,7 +7008,7 @@
                 <a:ea typeface="Bitstream Charter"/>
                 <a:cs typeface="Bitstream Charter"/>
               </a:rPr>
-              <a:t>and visit candidates</a:t>
+              <a:t>Site assessment</a:t>
             </a:r>
           </a:p>
         </p:txBody>
@@ -6901,6 +7047,7 @@
           <a:lstStyle xmlns:a="http://schemas.openxmlformats.org/drawingml/2006/main"/>
           <a:p xmlns:a="http://schemas.openxmlformats.org/drawingml/2006/main">
             <a:pPr>
+              <a:buNone/>
               <a:defRPr sz="1725" b="0">
                 <a:solidFill>
                   <a:srgbClr val="526569"/>
@@ -6987,6 +7134,7 @@
           <a:lstStyle xmlns:a="http://schemas.openxmlformats.org/drawingml/2006/main"/>
           <a:p xmlns:a="http://schemas.openxmlformats.org/drawingml/2006/main">
             <a:pPr>
+              <a:buNone/>
               <a:defRPr sz="3300" b="1">
                 <a:solidFill>
                   <a:srgbClr val="163D46"/>
@@ -7012,20 +7160,20 @@
       </p:sp>
       <p:pic>
         <p:nvPicPr>
-          <p:cNvPr id="5" name=""/>
+          <p:cNvPr id="7" name=""/>
           <p:cNvPicPr>
             <a:picLocks xmlns:a="http://schemas.openxmlformats.org/drawingml/2006/main" noChangeAspect="1"/>
           </p:cNvPicPr>
           <p:nvPr/>
         </p:nvPicPr>
         <p:blipFill>
-          <a:blip xmlns:r="http://schemas.openxmlformats.org/officeDocument/2006/relationships" xmlns:a="http://schemas.openxmlformats.org/drawingml/2006/main" r:embed="Rea9ba0e8114e44ed"/>
+          <a:blip xmlns:r="http://schemas.openxmlformats.org/officeDocument/2006/relationships" xmlns:a="http://schemas.openxmlformats.org/drawingml/2006/main" r:embed="Re0168ebde06e4c1b"/>
           <a:stretch xmlns:a="http://schemas.openxmlformats.org/drawingml/2006/main"/>
         </p:blipFill>
         <p:spPr>
           <a:xfrm xmlns:a="http://schemas.openxmlformats.org/drawingml/2006/main">
-            <a:off x="609600" y="1415415"/>
-            <a:ext cx="10972800" cy="4389120"/>
+            <a:off x="1706880" y="1415415"/>
+            <a:ext cx="8778240" cy="4389120"/>
           </a:xfrm>
           <a:prstGeom xmlns:a="http://schemas.openxmlformats.org/drawingml/2006/main" prst="rect">
             <a:avLst/>
@@ -7066,6 +7214,7 @@
           <a:lstStyle xmlns:a="http://schemas.openxmlformats.org/drawingml/2006/main"/>
           <a:p xmlns:a="http://schemas.openxmlformats.org/drawingml/2006/main">
             <a:pPr>
+              <a:buNone/>
               <a:defRPr sz="1725" b="0">
                 <a:solidFill>
                   <a:srgbClr val="526569"/>
@@ -7152,6 +7301,7 @@
           <a:lstStyle xmlns:a="http://schemas.openxmlformats.org/drawingml/2006/main"/>
           <a:p xmlns:a="http://schemas.openxmlformats.org/drawingml/2006/main">
             <a:pPr>
+              <a:buNone/>
               <a:defRPr sz="3300" b="1">
                 <a:solidFill>
                   <a:srgbClr val="163D46"/>
@@ -7177,20 +7327,20 @@
       </p:sp>
       <p:pic>
         <p:nvPicPr>
-          <p:cNvPr id="5" name=""/>
+          <p:cNvPr id="7" name=""/>
           <p:cNvPicPr>
             <a:picLocks xmlns:a="http://schemas.openxmlformats.org/drawingml/2006/main" noChangeAspect="1"/>
           </p:cNvPicPr>
           <p:nvPr/>
         </p:nvPicPr>
         <p:blipFill>
-          <a:blip xmlns:r="http://schemas.openxmlformats.org/officeDocument/2006/relationships" xmlns:a="http://schemas.openxmlformats.org/drawingml/2006/main" r:embed="Rd0e2a96bb88e4083"/>
+          <a:blip xmlns:r="http://schemas.openxmlformats.org/officeDocument/2006/relationships" xmlns:a="http://schemas.openxmlformats.org/drawingml/2006/main" r:embed="R8f42fadd3d094151"/>
           <a:stretch xmlns:a="http://schemas.openxmlformats.org/drawingml/2006/main"/>
         </p:blipFill>
         <p:spPr>
           <a:xfrm xmlns:a="http://schemas.openxmlformats.org/drawingml/2006/main">
-            <a:off x="695325" y="1295400"/>
-            <a:ext cx="10801350" cy="4629150"/>
+            <a:off x="1081088" y="1295400"/>
+            <a:ext cx="10029825" cy="4629150"/>
           </a:xfrm>
           <a:prstGeom xmlns:a="http://schemas.openxmlformats.org/drawingml/2006/main" prst="rect">
             <a:avLst/>
@@ -7231,6 +7381,7 @@
           <a:lstStyle xmlns:a="http://schemas.openxmlformats.org/drawingml/2006/main"/>
           <a:p xmlns:a="http://schemas.openxmlformats.org/drawingml/2006/main">
             <a:pPr>
+              <a:buNone/>
               <a:defRPr sz="1725" b="0">
                 <a:solidFill>
                   <a:srgbClr val="526569"/>
@@ -7317,6 +7468,7 @@
           <a:lstStyle xmlns:a="http://schemas.openxmlformats.org/drawingml/2006/main"/>
           <a:p xmlns:a="http://schemas.openxmlformats.org/drawingml/2006/main">
             <a:pPr>
+              <a:buNone/>
               <a:defRPr sz="3300" b="1">
                 <a:solidFill>
                   <a:srgbClr val="163D46"/>
@@ -7342,7 +7494,7 @@
       </p:sp>
       <p:graphicFrame>
         <p:nvGraphicFramePr>
-          <p:cNvPr id="7" name=""/>
+          <p:cNvPr id="9" name=""/>
           <p:cNvGraphicFramePr/>
           <p:nvPr/>
         </p:nvGraphicFramePr>
@@ -7827,6 +7979,7 @@
           <a:lstStyle xmlns:a="http://schemas.openxmlformats.org/drawingml/2006/main"/>
           <a:p xmlns:a="http://schemas.openxmlformats.org/drawingml/2006/main">
             <a:pPr>
+              <a:buNone/>
               <a:defRPr sz="2400" b="0">
                 <a:solidFill>
                   <a:srgbClr val="213846"/>
@@ -7845,7 +7998,7 @@
                 <a:ea typeface="Bitstream Charter"/>
                 <a:cs typeface="Bitstream Charter"/>
               </a:rPr>
-              <a:t>Score: 50% temperature percentile, 30% inverse green percentile, 20% mapped-building percentile.</a:t>
+              <a:t>Bus-stop road: inspect waiting-time shade and access. Parking: check event use. Hospital land: confirm planned use.</a:t>
             </a:r>
           </a:p>
         </p:txBody>
@@ -7884,6 +8037,7 @@
           <a:lstStyle xmlns:a="http://schemas.openxmlformats.org/drawingml/2006/main"/>
           <a:p xmlns:a="http://schemas.openxmlformats.org/drawingml/2006/main">
             <a:pPr>
+              <a:buNone/>
               <a:defRPr sz="2400" b="0">
                 <a:solidFill>
                   <a:srgbClr val="213846"/>
@@ -7902,7 +8056,7 @@
                 <a:ea typeface="Bitstream Charter"/>
                 <a:cs typeface="Bitstream Charter"/>
               </a:rPr>
-              <a:t>Thirteen sensitivity settings show no uniquely verified best intervention site.</a:t>
+              <a:t>0% detected greenery does not mean no trees. V04-23's NDVI maxima are below 0.30; its ranking stays unchanged.</a:t>
             </a:r>
           </a:p>
         </p:txBody>
@@ -7941,6 +8095,7 @@
           <a:lstStyle xmlns:a="http://schemas.openxmlformats.org/drawingml/2006/main"/>
           <a:p xmlns:a="http://schemas.openxmlformats.org/drawingml/2006/main">
             <a:pPr>
+              <a:buNone/>
               <a:defRPr sz="1725" b="0">
                 <a:solidFill>
                   <a:srgbClr val="526569"/>
@@ -8027,6 +8182,7 @@
           <a:lstStyle xmlns:a="http://schemas.openxmlformats.org/drawingml/2006/main"/>
           <a:p xmlns:a="http://schemas.openxmlformats.org/drawingml/2006/main">
             <a:pPr>
+              <a:buNone/>
               <a:defRPr sz="3300" b="1">
                 <a:solidFill>
                   <a:srgbClr val="163D46"/>
@@ -8084,6 +8240,7 @@
           <a:lstStyle xmlns:a="http://schemas.openxmlformats.org/drawingml/2006/main"/>
           <a:p xmlns:a="http://schemas.openxmlformats.org/drawingml/2006/main">
             <a:pPr>
+              <a:buNone/>
               <a:defRPr sz="2400" b="0">
                 <a:solidFill>
                   <a:srgbClr val="213846"/>
@@ -8141,6 +8298,7 @@
           <a:lstStyle xmlns:a="http://schemas.openxmlformats.org/drawingml/2006/main"/>
           <a:p xmlns:a="http://schemas.openxmlformats.org/drawingml/2006/main">
             <a:pPr>
+              <a:buNone/>
               <a:defRPr sz="2400" b="0">
                 <a:solidFill>
                   <a:srgbClr val="213846"/>
@@ -8198,6 +8356,7 @@
           <a:lstStyle xmlns:a="http://schemas.openxmlformats.org/drawingml/2006/main"/>
           <a:p xmlns:a="http://schemas.openxmlformats.org/drawingml/2006/main">
             <a:pPr>
+              <a:buNone/>
               <a:defRPr sz="2400" b="0">
                 <a:solidFill>
                   <a:srgbClr val="213846"/>
@@ -8216,7 +8375,7 @@
                 <a:ea typeface="Bitstream Charter"/>
                 <a:cs typeface="Bitstream Charter"/>
               </a:rPr>
-              <a:t>Grass reference agreement: 24/25. Building green-rule agreement: 0/30. Coastal points retained in thermal support: 0/30.</a:t>
+              <a:t>Optical rule checks: 24/25 grass points pass; 0/30 building points pass. All 30 coastal points are excluded from thermal support.</a:t>
             </a:r>
           </a:p>
         </p:txBody>
@@ -8255,6 +8414,7 @@
           <a:lstStyle xmlns:a="http://schemas.openxmlformats.org/drawingml/2006/main"/>
           <a:p xmlns:a="http://schemas.openxmlformats.org/drawingml/2006/main">
             <a:pPr>
+              <a:buNone/>
               <a:defRPr sz="1725" b="0">
                 <a:solidFill>
                   <a:srgbClr val="526569"/>

</xml_diff>